<commit_message>
feat: embed original project presentations, documentation files, and cloud links for all 5 product/ML projects
</commit_message>
<xml_diff>
--- a/01_мультиагентный_конвейер_стратегии_газпром/gazprom_executive_deck.pptx
+++ b/01_мультиагентный_конвейер_стратегии_газпром/gazprom_executive_deck.pptx
@@ -3245,7 +3245,7 @@
               </a:defRPr>
             </a:pPr>
             <a:r>
-              <a:t>Сквозной выпуск: RUN_20260916_104401 [ЖИВОЙ ОНЛАЙН-ПАРСИНГ] • 2026-09-16 10:44:01</a:t>
+              <a:t>Сквозной выпуск: RUN_20260916_105215 [ЖИВОЙ ОНЛАЙН-ПАРСИНГ] • 2026-09-16 10:52:15</a:t>
             </a:r>
           </a:p>
           <a:p>
@@ -3463,7 +3463,7 @@
               </a:defRPr>
             </a:pPr>
             <a:r>
-              <a:t>WSJ: нефтяные компании США объявили о начале глобального топливного кризиса</a:t>
+              <a:t>Алиханов предложил создать «национального нефтесервисного чемпиона» // Глава Минпромторга Алиханов предложил объединить усилия нефтесервисных компаний</a:t>
             </a:r>
           </a:p>
           <a:p>
@@ -3523,7 +3523,7 @@
               </a:defRPr>
             </a:pPr>
             <a:r>
-              <a:t>Глобальный топливный кризис, о котором предупреждали крупнейшие нефтяные компании мира, уже наступил. Руководители американских Chevron и ExxonMobil заявляют, что длительная блокировка Ормузского пролива и атака на нефтепровод «Восток -- Запад» в Саудовской Аравии привели к серье...</a:t>
+              <a:t>Министерство промышленности и торговли обсуждает объединение усилий предприятий и регионов для развития российских нефтесервисных предприятий. Глава ведомства Антон Алиханов призывает к созданию «национального чемпиона» в этой отрасли для продвижения технологий и оборудования на ...</a:t>
             </a:r>
           </a:p>
           <a:p>

</xml_diff>